<commit_message>
Put the demo and repository links on the deck, as real hyperlinks
The repository URL was only on the last slide in small grey text, and neither
link was clickable. Both now appear on the title page, beside the demo QR on
the impact slide, and on the references slide, and every one of them carries an
actual hyperlink rather than styled text - so a judge reading the submitted PDF
is one click from the running demo instead of retyping a URL.

Verified after export: all six links survive the PDF conversion.
</commit_message>
<xml_diff>
--- a/deck/SIH2026_800C4B_SETU_PS26166.pptx
+++ b/deck/SIH2026_800C4B_SETU_PS26166.pptx
@@ -5907,8 +5907,8 @@
         </p:nvSpPr>
         <p:spPr>
           <a:xfrm>
-            <a:off x="329184" y="5532120"/>
-            <a:ext cx="6309360" cy="1005840"/>
+            <a:off x="329184" y="5358384"/>
+            <a:ext cx="8778240" cy="1371600"/>
           </a:xfrm>
           <a:prstGeom prst="rect">
             <a:avLst/>
@@ -5933,7 +5933,7 @@
               </a:spcAft>
             </a:pPr>
             <a:r>
-              <a:rPr sz="2200" b="1" i="0">
+              <a:rPr sz="2100" b="1" i="0">
                 <a:solidFill>
                   <a:srgbClr val="1F3B73"/>
                 </a:solidFill>
@@ -5951,17 +5951,65 @@
                 <a:spcPts val="0"/>
               </a:spcBef>
               <a:spcAft>
-                <a:spcPts val="400"/>
+                <a:spcPts val="700"/>
               </a:spcAft>
             </a:pPr>
             <a:r>
-              <a:rPr sz="1150" b="0" i="1">
+              <a:rPr sz="1100" b="0" i="1">
                 <a:solidFill>
                   <a:srgbClr val="0E7FBF"/>
                 </a:solidFill>
                 <a:latin typeface="Calibri"/>
               </a:rPr>
               <a:t>Geometry for scale and viewpoint. Physics for the Sun. Learning only for what is left.</a:t>
+            </a:r>
+          </a:p>
+          <a:p>
+            <a:pPr>
+              <a:lnSpc>
+                <a:spcPct val="105000"/>
+              </a:lnSpc>
+              <a:spcAft>
+                <a:spcPts val="0"/>
+              </a:spcAft>
+            </a:pPr>
+            <a:r>
+              <a:rPr sz="1000" b="1">
+                <a:solidFill>
+                  <a:srgbClr val="12233D"/>
+                </a:solidFill>
+                <a:latin typeface="Calibri"/>
+              </a:rPr>
+              <a:t>Live demo   </a:t>
+            </a:r>
+            <a:r>
+              <a:rPr sz="1000" b="0">
+                <a:solidFill>
+                  <a:srgbClr val="0E7FBF"/>
+                </a:solidFill>
+                <a:latin typeface="Calibri"/>
+                <a:hlinkClick r:id="rId4"/>
+              </a:rPr>
+              <a:t>https://arya-patil686.github.io/setu-sih2026/</a:t>
+            </a:r>
+            <a:r>
+              <a:rPr sz="1000" b="1">
+                <a:solidFill>
+                  <a:srgbClr val="12233D"/>
+                </a:solidFill>
+                <a:latin typeface="Calibri"/>
+              </a:rPr>
+              <a:t>      Code   </a:t>
+            </a:r>
+            <a:r>
+              <a:rPr sz="1000" b="0">
+                <a:solidFill>
+                  <a:srgbClr val="0E7FBF"/>
+                </a:solidFill>
+                <a:latin typeface="Calibri"/>
+                <a:hlinkClick r:id="rId5"/>
+              </a:rPr>
+              <a:t>https://github.com/Arya-Patil686/setu-sih2026</a:t>
             </a:r>
           </a:p>
         </p:txBody>
@@ -9009,8 +9057,8 @@
         </p:nvSpPr>
         <p:spPr>
           <a:xfrm>
-            <a:off x="1810512" y="5138928"/>
-            <a:ext cx="9875520" cy="960120"/>
+            <a:off x="1810512" y="5065776"/>
+            <a:ext cx="9875520" cy="1097280"/>
           </a:xfrm>
           <a:prstGeom prst="rect">
             <a:avLst/>
@@ -9035,41 +9083,59 @@
               </a:spcAft>
             </a:pPr>
             <a:r>
-              <a:rPr sz="900" b="1" i="0">
+              <a:rPr sz="860" b="1" i="0">
                 <a:solidFill>
                   <a:srgbClr val="0F764B"/>
                 </a:solidFill>
                 <a:latin typeface="Calibri"/>
               </a:rPr>
-              <a:t>TRY IT LIVE</a:t>
-            </a:r>
-          </a:p>
-          <a:p>
-            <a:pPr algn="l">
+              <a:t>TRY IT LIVE, AND READ THE CODE</a:t>
+            </a:r>
+          </a:p>
+          <a:p>
+            <a:pPr>
               <a:lnSpc>
-                <a:spcPct val="100000"/>
+                <a:spcPct val="105000"/>
               </a:lnSpc>
-              <a:spcBef>
-                <a:spcPts val="0"/>
-              </a:spcBef>
+              <a:spcAft>
+                <a:spcPts val="200"/>
+              </a:spcAft>
+            </a:pPr>
+            <a:r>
+              <a:rPr sz="1250" b="1">
+                <a:solidFill>
+                  <a:srgbClr val="0F764B"/>
+                </a:solidFill>
+                <a:latin typeface="Calibri"/>
+                <a:hlinkClick r:id="rId6"/>
+              </a:rPr>
+              <a:t>https://arya-patil686.github.io/setu-sih2026/</a:t>
+            </a:r>
+          </a:p>
+          <a:p>
+            <a:pPr>
+              <a:lnSpc>
+                <a:spcPct val="105000"/>
+              </a:lnSpc>
               <a:spcAft>
                 <a:spcPts val="300"/>
               </a:spcAft>
             </a:pPr>
             <a:r>
-              <a:rPr sz="1350" b="1" i="0">
-                <a:solidFill>
-                  <a:srgbClr val="0F764B"/>
-                </a:solidFill>
-                <a:latin typeface="Calibri"/>
-              </a:rPr>
-              <a:t>https://arya-patil686.github.io/setu-sih2026/</a:t>
+              <a:rPr sz="1050" b="1">
+                <a:solidFill>
+                  <a:srgbClr val="1F3B73"/>
+                </a:solidFill>
+                <a:latin typeface="Calibri"/>
+                <a:hlinkClick r:id="rId7"/>
+              </a:rPr>
+              <a:t>https://github.com/Arya-Patil686/setu-sih2026</a:t>
             </a:r>
           </a:p>
           <a:p>
             <a:pPr algn="l">
               <a:lnSpc>
-                <a:spcPct val="105000"/>
+                <a:spcPct val="104000"/>
               </a:lnSpc>
               <a:spcBef>
                 <a:spcPts val="0"/>
@@ -9079,7 +9145,7 @@
               </a:spcAft>
             </a:pPr>
             <a:r>
-              <a:rPr sz="900" b="0" i="0">
+              <a:rPr sz="860" b="0" i="0">
                 <a:solidFill>
                   <a:srgbClr val="41546F"/>
                 </a:solidFill>
@@ -10048,21 +10114,19 @@
           <a:p>
             <a:pPr algn="ctr">
               <a:lnSpc>
-                <a:spcPct val="100000"/>
+                <a:spcPct val="105000"/>
               </a:lnSpc>
-              <a:spcBef>
-                <a:spcPts val="0"/>
-              </a:spcBef>
               <a:spcAft>
                 <a:spcPts val="400"/>
               </a:spcAft>
             </a:pPr>
             <a:r>
-              <a:rPr sz="940" b="1" i="0">
+              <a:rPr sz="940" b="1">
                 <a:solidFill>
                   <a:srgbClr val="0E7FBF"/>
                 </a:solidFill>
                 <a:latin typeface="Calibri"/>
+                <a:hlinkClick r:id="rId5"/>
               </a:rPr>
               <a:t>https://arya-patil686.github.io/setu-sih2026/</a:t>
             </a:r>
@@ -10070,21 +10134,19 @@
           <a:p>
             <a:pPr algn="ctr">
               <a:lnSpc>
-                <a:spcPct val="100000"/>
+                <a:spcPct val="105000"/>
               </a:lnSpc>
-              <a:spcBef>
-                <a:spcPts val="0"/>
-              </a:spcBef>
               <a:spcAft>
                 <a:spcPts val="0"/>
               </a:spcAft>
             </a:pPr>
             <a:r>
-              <a:rPr sz="860" b="0" i="0">
+              <a:rPr sz="860" b="0">
                 <a:solidFill>
                   <a:srgbClr val="41546F"/>
                 </a:solidFill>
                 <a:latin typeface="Calibri"/>
+                <a:hlinkClick r:id="rId6"/>
               </a:rPr>
               <a:t>https://github.com/Arya-Patil686/setu-sih2026</a:t>
             </a:r>

</xml_diff>